<commit_message>
Add interval and coverage explainer slide with illustration
Co-Authored-By: Claude Opus 4.8 <noreply@anthropic.com>
</commit_message>
<xml_diff>
--- a/REE_Results_Slides.pptx
+++ b/REE_Results_Slides.pptx
@@ -25,6 +25,7 @@
     <p:sldId id="273" r:id="rId24"/>
     <p:sldId id="274" r:id="rId25"/>
     <p:sldId id="275" r:id="rId26"/>
+    <p:sldId id="276" r:id="rId27"/>
   </p:sldIdLst>
   <p:sldSz cx="12191695" cy="6858000" type="screen4x3"/>
   <p:notesSz cx="6858000" cy="9144000"/>
@@ -3269,14 +3270,14 @@
                 </a:solidFill>
                 <a:latin typeface="Arial"/>
               </a:rPr>
-              <a:t>Confidence versus error, by metal</a:t>
+              <a:t>Confidence by metal</a:t>
             </a:r>
           </a:p>
         </p:txBody>
       </p:sp>
       <p:pic>
         <p:nvPicPr>
-          <p:cNvPr id="3" name="Picture 2" descr="by_metal_confidence_vs_error.png"/>
+          <p:cNvPr id="3" name="Picture 2" descr="confidence_per_metal.png"/>
           <p:cNvPicPr>
             <a:picLocks noChangeAspect="1"/>
           </p:cNvPicPr>
@@ -3290,8 +3291,8 @@
         </p:blipFill>
         <p:spPr>
           <a:xfrm>
-            <a:off x="3267777" y="1508760"/>
-            <a:ext cx="5656139" cy="3931920"/>
+            <a:off x="2308061" y="1508760"/>
+            <a:ext cx="7575571" cy="4297680"/>
           </a:xfrm>
           <a:prstGeom prst="rect">
             <a:avLst/>
@@ -3306,7 +3307,7 @@
         </p:nvSpPr>
         <p:spPr>
           <a:xfrm>
-            <a:off x="640080" y="5586983"/>
+            <a:off x="640080" y="5952744"/>
             <a:ext cx="10881360" cy="1005840"/>
           </a:xfrm>
           <a:prstGeom prst="rect">
@@ -3332,7 +3333,7 @@
                 </a:solidFill>
                 <a:latin typeface="Arial"/>
               </a:rPr>
-              <a:t>The horizontal axis is the model's estimated error and the vertical axis is the actual error. They line up, so Americium and Curium sit low on both while Neptunium(V), Uranium(VI), and Erbium sit high on both, which is what lets the model flag the metals it cannot predict well.</a:t>
+              <a:t>Each bar is the model's median estimated error for a metal, which is its confidence signal, so a shorter bar means it is more sure. The model is most confident on Americium and Curium and least confident on Neptunium(V), Uranium(VI), and Erbium.</a:t>
             </a:r>
           </a:p>
         </p:txBody>
@@ -3397,14 +3398,14 @@
                 </a:solidFill>
                 <a:latin typeface="Arial"/>
               </a:rPr>
-              <a:t>Separation between metal pairs</a:t>
+              <a:t>Confidence versus error, by metal</a:t>
             </a:r>
           </a:p>
         </p:txBody>
       </p:sp>
       <p:pic>
         <p:nvPicPr>
-          <p:cNvPr id="3" name="Picture 2" descr="by_metal_pair_separation.png"/>
+          <p:cNvPr id="3" name="Picture 2" descr="by_metal_confidence_vs_error.png"/>
           <p:cNvPicPr>
             <a:picLocks noChangeAspect="1"/>
           </p:cNvPicPr>
@@ -3418,8 +3419,8 @@
         </p:blipFill>
         <p:spPr>
           <a:xfrm>
-            <a:off x="900040" y="1508760"/>
-            <a:ext cx="10391613" cy="4114800"/>
+            <a:off x="3267777" y="1508760"/>
+            <a:ext cx="5656139" cy="3931920"/>
           </a:xfrm>
           <a:prstGeom prst="rect">
             <a:avLst/>
@@ -3434,7 +3435,7 @@
         </p:nvSpPr>
         <p:spPr>
           <a:xfrm>
-            <a:off x="640080" y="5769864"/>
+            <a:off x="640080" y="5586983"/>
             <a:ext cx="10881360" cy="1005840"/>
           </a:xfrm>
           <a:prstGeom prst="rect">
@@ -3460,7 +3461,7 @@
                 </a:solidFill>
                 <a:latin typeface="Arial"/>
               </a:rPr>
-              <a:t>A separation is the logD difference between two metals at the same conditions. Pairs far apart in logD such as Dysprosium and Ytterbium are predicted well, while tight adjacent pairs such as Erbium and Terbium are hardest, which is the case that matters most for industry.</a:t>
+              <a:t>The horizontal axis is the model's estimated error and the vertical axis is the actual error. They line up, so Americium and Curium sit low on both while Neptunium(V), Uranium(VI), and Erbium sit high on both, which is what lets the model flag the metals it cannot predict well.</a:t>
             </a:r>
           </a:p>
         </p:txBody>
@@ -3525,14 +3526,14 @@
                 </a:solidFill>
                 <a:latin typeface="Arial"/>
               </a:rPr>
-              <a:t>Confidence by metal pair</a:t>
+              <a:t>Separation between metal pairs</a:t>
             </a:r>
           </a:p>
         </p:txBody>
       </p:sp>
       <p:pic>
         <p:nvPicPr>
-          <p:cNvPr id="3" name="Picture 2" descr="by_pair_confidence_vs_error.png"/>
+          <p:cNvPr id="3" name="Picture 2" descr="by_metal_pair_separation.png"/>
           <p:cNvPicPr>
             <a:picLocks noChangeAspect="1"/>
           </p:cNvPicPr>
@@ -3546,8 +3547,8 @@
         </p:blipFill>
         <p:spPr>
           <a:xfrm>
-            <a:off x="2728891" y="1508760"/>
-            <a:ext cx="6733912" cy="3931920"/>
+            <a:off x="900040" y="1508760"/>
+            <a:ext cx="10391613" cy="4114800"/>
           </a:xfrm>
           <a:prstGeom prst="rect">
             <a:avLst/>
@@ -3562,7 +3563,7 @@
         </p:nvSpPr>
         <p:spPr>
           <a:xfrm>
-            <a:off x="640080" y="5586983"/>
+            <a:off x="640080" y="5769864"/>
             <a:ext cx="10881360" cy="1005840"/>
           </a:xfrm>
           <a:prstGeom prst="rect">
@@ -3588,7 +3589,7 @@
                 </a:solidFill>
                 <a:latin typeface="Arial"/>
               </a:rPr>
-              <a:t>Confidence behaves the same way on pairs: the model's estimated error for a pair lines up with the actual separation error, so it is most confident on the easy far-apart pairs and least confident on hard adjacent pairs such as Erbium and Terbium.</a:t>
+              <a:t>A separation is the logD difference between two metals at the same conditions. Pairs far apart in logD such as Dysprosium and Ytterbium are predicted well, while tight adjacent pairs such as Erbium and Terbium are hardest, which is the case that matters most for industry.</a:t>
             </a:r>
           </a:p>
         </p:txBody>
@@ -3653,14 +3654,14 @@
                 </a:solidFill>
                 <a:latin typeface="Arial"/>
               </a:rPr>
-              <a:t>Ensemble weights</a:t>
+              <a:t>Confidence by metal pair</a:t>
             </a:r>
           </a:p>
         </p:txBody>
       </p:sp>
       <p:pic>
         <p:nvPicPr>
-          <p:cNvPr id="3" name="Picture 2" descr="ensemble_weights.png"/>
+          <p:cNvPr id="3" name="Picture 2" descr="by_pair_confidence_vs_error.png"/>
           <p:cNvPicPr>
             <a:picLocks noChangeAspect="1"/>
           </p:cNvPicPr>
@@ -3674,8 +3675,8 @@
         </p:blipFill>
         <p:spPr>
           <a:xfrm>
-            <a:off x="792327" y="1508760"/>
-            <a:ext cx="10607040" cy="3795179"/>
+            <a:off x="2728891" y="1508760"/>
+            <a:ext cx="6733912" cy="3931920"/>
           </a:xfrm>
           <a:prstGeom prst="rect">
             <a:avLst/>
@@ -3690,7 +3691,7 @@
         </p:nvSpPr>
         <p:spPr>
           <a:xfrm>
-            <a:off x="640080" y="5450243"/>
+            <a:off x="640080" y="5586983"/>
             <a:ext cx="10881360" cy="1005840"/>
           </a:xfrm>
           <a:prstGeom prst="rect">
@@ -3716,7 +3717,7 @@
                 </a:solidFill>
                 <a:latin typeface="Arial"/>
               </a:rPr>
-              <a:t>Non-negative least squares keeps only the members that help, leaving ExtraTrees, LightGBM, and XGBoost on Track B and dropping the rest to a weight of zero.</a:t>
+              <a:t>Confidence behaves the same way on pairs: the model's estimated error for a pair lines up with the actual separation error, so it is most confident on the easy far-apart pairs and least confident on hard adjacent pairs such as Erbium and Terbium.</a:t>
             </a:r>
           </a:p>
         </p:txBody>
@@ -3781,14 +3782,14 @@
                 </a:solidFill>
                 <a:latin typeface="Arial"/>
               </a:rPr>
-              <a:t>Uncertainty intervals</a:t>
+              <a:t>Ensemble weights</a:t>
             </a:r>
           </a:p>
         </p:txBody>
       </p:sp>
       <p:pic>
         <p:nvPicPr>
-          <p:cNvPr id="3" name="Picture 2" descr="conformal_calibration.png"/>
+          <p:cNvPr id="3" name="Picture 2" descr="ensemble_weights.png"/>
           <p:cNvPicPr>
             <a:picLocks noChangeAspect="1"/>
           </p:cNvPicPr>
@@ -3844,7 +3845,7 @@
                 </a:solidFill>
                 <a:latin typeface="Arial"/>
               </a:rPr>
-              <a:t>Each prediction comes with a range. A 90 percent interval is built to contain the true logD about 90 percent of the time, an 80 percent interval about 80 percent. The left bars show the measured coverage (0.89 to 0.90 and 0.79 to 0.80), so the ranges are honest; the right bars show the typical width, narrower on Track B.</a:t>
+              <a:t>Non-negative least squares keeps only the members that help, leaving ExtraTrees, LightGBM, and XGBoost on Track B and dropping the rest to a weight of zero.</a:t>
             </a:r>
           </a:p>
         </p:txBody>
@@ -3909,21 +3910,45 @@
                 </a:solidFill>
                 <a:latin typeface="Arial"/>
               </a:rPr>
-              <a:t>Comparison with Dr. Zhang's model</a:t>
-            </a:r>
-          </a:p>
-        </p:txBody>
-      </p:sp>
-      <p:sp>
-        <p:nvSpPr>
-          <p:cNvPr id="3" name="TextBox 2"/>
+              <a:t>Uncertainty intervals</a:t>
+            </a:r>
+          </a:p>
+        </p:txBody>
+      </p:sp>
+      <p:pic>
+        <p:nvPicPr>
+          <p:cNvPr id="3" name="Picture 2" descr="conformal_calibration.png"/>
+          <p:cNvPicPr>
+            <a:picLocks noChangeAspect="1"/>
+          </p:cNvPicPr>
+          <p:nvPr/>
+        </p:nvPicPr>
+        <p:blipFill>
+          <a:blip r:embed="rId2"/>
+          <a:stretch>
+            <a:fillRect/>
+          </a:stretch>
+        </p:blipFill>
+        <p:spPr>
+          <a:xfrm>
+            <a:off x="792327" y="1508760"/>
+            <a:ext cx="10607040" cy="3795179"/>
+          </a:xfrm>
+          <a:prstGeom prst="rect">
+            <a:avLst/>
+          </a:prstGeom>
+        </p:spPr>
+      </p:pic>
+      <p:sp>
+        <p:nvSpPr>
+          <p:cNvPr id="4" name="TextBox 3"/>
           <p:cNvSpPr txBox="1"/>
           <p:nvPr/>
         </p:nvSpPr>
         <p:spPr>
           <a:xfrm>
-            <a:off x="640080" y="1645920"/>
-            <a:ext cx="10972800" cy="3657600"/>
+            <a:off x="640080" y="5450243"/>
+            <a:ext cx="10881360" cy="1005840"/>
           </a:xfrm>
           <a:prstGeom prst="rect">
             <a:avLst/>
@@ -3938,49 +3963,17 @@
           <a:p>
             <a:pPr algn="l">
               <a:spcAft>
-                <a:spcPts val="1400"/>
-              </a:spcAft>
-            </a:pPr>
-            <a:r>
-              <a:rPr sz="1800" b="0" i="0">
-                <a:solidFill>
-                  <a:srgbClr val="000000"/>
-                </a:solidFill>
-                <a:latin typeface="Arial"/>
-              </a:rPr>
-              <a:t>Both projects use the same 8,075-row f-element dataset (295 molecules, 28 metals), so the comparison is fair on the data.</a:t>
-            </a:r>
-          </a:p>
-          <a:p>
-            <a:pPr algn="l">
-              <a:spcAft>
-                <a:spcPts val="1400"/>
-              </a:spcAft>
-            </a:pPr>
-            <a:r>
-              <a:rPr sz="1800" b="0" i="0">
-                <a:solidFill>
-                  <a:srgbClr val="000000"/>
-                </a:solidFill>
-                <a:latin typeface="Arial"/>
-              </a:rPr>
-              <a:t>His supervised model is a 3-class XGBoost classifier that reports 72 percent accuracy on one 494-row held-out test, with no way to rank which predictions to trust.</a:t>
-            </a:r>
-          </a:p>
-          <a:p>
-            <a:pPr algn="l">
-              <a:spcAft>
                 <a:spcPts val="600"/>
               </a:spcAft>
             </a:pPr>
             <a:r>
-              <a:rPr sz="1800" b="0" i="0">
-                <a:solidFill>
-                  <a:srgbClr val="000000"/>
-                </a:solidFill>
-                <a:latin typeface="Arial"/>
-              </a:rPr>
-              <a:t>Ours predicts the continuous logD value with a confidence score and an uncertainty interval, and it can also be scored as a classifier on his exact task, which the next slides do.</a:t>
+              <a:rPr sz="1300" b="0" i="1">
+                <a:solidFill>
+                  <a:srgbClr val="404040"/>
+                </a:solidFill>
+                <a:latin typeface="Arial"/>
+              </a:rPr>
+              <a:t>Each prediction comes with a range. A 90 percent interval is built to contain the true logD about 90 percent of the time, an 80 percent interval about 80 percent. The left bars show the measured coverage (0.89 to 0.90 and 0.79 to 0.80), so the ranges are honest; the right bars show the typical width, narrower on Track B.</a:t>
             </a:r>
           </a:p>
         </p:txBody>
@@ -4045,45 +4038,21 @@
                 </a:solidFill>
                 <a:latin typeface="Arial"/>
               </a:rPr>
-              <a:t>Accuracy by confidence level, versus Zhang</a:t>
-            </a:r>
-          </a:p>
-        </p:txBody>
-      </p:sp>
-      <p:pic>
-        <p:nvPicPr>
-          <p:cNvPr id="3" name="Picture 2" descr="zhang_comparison_selective.png"/>
-          <p:cNvPicPr>
-            <a:picLocks noChangeAspect="1"/>
-          </p:cNvPicPr>
-          <p:nvPr/>
-        </p:nvPicPr>
-        <p:blipFill>
-          <a:blip r:embed="rId2"/>
-          <a:stretch>
-            <a:fillRect/>
-          </a:stretch>
-        </p:blipFill>
-        <p:spPr>
-          <a:xfrm>
-            <a:off x="2932411" y="1508760"/>
-            <a:ext cx="6326872" cy="3931920"/>
-          </a:xfrm>
-          <a:prstGeom prst="rect">
-            <a:avLst/>
-          </a:prstGeom>
-        </p:spPr>
-      </p:pic>
-      <p:sp>
-        <p:nvSpPr>
-          <p:cNvPr id="4" name="TextBox 3"/>
+              <a:t>Comparison with Dr. Zhang's model</a:t>
+            </a:r>
+          </a:p>
+        </p:txBody>
+      </p:sp>
+      <p:sp>
+        <p:nvSpPr>
+          <p:cNvPr id="3" name="TextBox 2"/>
           <p:cNvSpPr txBox="1"/>
           <p:nvPr/>
         </p:nvSpPr>
         <p:spPr>
           <a:xfrm>
-            <a:off x="640080" y="5586983"/>
-            <a:ext cx="10881360" cy="1005840"/>
+            <a:off x="640080" y="1645920"/>
+            <a:ext cx="10972800" cy="3657600"/>
           </a:xfrm>
           <a:prstGeom prst="rect">
             <a:avLst/>
@@ -4098,17 +4067,49 @@
           <a:p>
             <a:pPr algn="l">
               <a:spcAft>
+                <a:spcPts val="1400"/>
+              </a:spcAft>
+            </a:pPr>
+            <a:r>
+              <a:rPr sz="1800" b="0" i="0">
+                <a:solidFill>
+                  <a:srgbClr val="000000"/>
+                </a:solidFill>
+                <a:latin typeface="Arial"/>
+              </a:rPr>
+              <a:t>Both projects use the same 8,075-row f-element dataset (295 molecules, 28 metals), so the comparison is fair on the data.</a:t>
+            </a:r>
+          </a:p>
+          <a:p>
+            <a:pPr algn="l">
+              <a:spcAft>
+                <a:spcPts val="1400"/>
+              </a:spcAft>
+            </a:pPr>
+            <a:r>
+              <a:rPr sz="1800" b="0" i="0">
+                <a:solidFill>
+                  <a:srgbClr val="000000"/>
+                </a:solidFill>
+                <a:latin typeface="Arial"/>
+              </a:rPr>
+              <a:t>His supervised model is a 3-class XGBoost classifier that reports 72 percent accuracy on one 494-row held-out test, with no way to rank which predictions to trust.</a:t>
+            </a:r>
+          </a:p>
+          <a:p>
+            <a:pPr algn="l">
+              <a:spcAft>
                 <a:spcPts val="600"/>
               </a:spcAft>
             </a:pPr>
             <a:r>
-              <a:rPr sz="1300" b="0" i="1">
-                <a:solidFill>
-                  <a:srgbClr val="404040"/>
-                </a:solidFill>
-                <a:latin typeface="Arial"/>
-              </a:rPr>
-              <a:t>His 0.72 is a single value over all molecules. Ours can be ranked by confidence, so on the predictions it is most sure about it is far more accurate, which a single value cannot offer.</a:t>
+              <a:rPr sz="1800" b="0" i="0">
+                <a:solidFill>
+                  <a:srgbClr val="000000"/>
+                </a:solidFill>
+                <a:latin typeface="Arial"/>
+              </a:rPr>
+              <a:t>Ours predicts the continuous logD value with a confidence score and an uncertainty interval, and it can also be scored as a classifier on his exact task, which the next slides do.</a:t>
             </a:r>
           </a:p>
         </p:txBody>
@@ -4173,6 +4174,134 @@
                 </a:solidFill>
                 <a:latin typeface="Arial"/>
               </a:rPr>
+              <a:t>Accuracy by confidence level, versus Zhang</a:t>
+            </a:r>
+          </a:p>
+        </p:txBody>
+      </p:sp>
+      <p:pic>
+        <p:nvPicPr>
+          <p:cNvPr id="3" name="Picture 2" descr="zhang_comparison_selective.png"/>
+          <p:cNvPicPr>
+            <a:picLocks noChangeAspect="1"/>
+          </p:cNvPicPr>
+          <p:nvPr/>
+        </p:nvPicPr>
+        <p:blipFill>
+          <a:blip r:embed="rId2"/>
+          <a:stretch>
+            <a:fillRect/>
+          </a:stretch>
+        </p:blipFill>
+        <p:spPr>
+          <a:xfrm>
+            <a:off x="2932411" y="1508760"/>
+            <a:ext cx="6326872" cy="3931920"/>
+          </a:xfrm>
+          <a:prstGeom prst="rect">
+            <a:avLst/>
+          </a:prstGeom>
+        </p:spPr>
+      </p:pic>
+      <p:sp>
+        <p:nvSpPr>
+          <p:cNvPr id="4" name="TextBox 3"/>
+          <p:cNvSpPr txBox="1"/>
+          <p:nvPr/>
+        </p:nvSpPr>
+        <p:spPr>
+          <a:xfrm>
+            <a:off x="640080" y="5586983"/>
+            <a:ext cx="10881360" cy="1005840"/>
+          </a:xfrm>
+          <a:prstGeom prst="rect">
+            <a:avLst/>
+          </a:prstGeom>
+          <a:noFill/>
+        </p:spPr>
+        <p:txBody>
+          <a:bodyPr wrap="square" lIns="0" rIns="0" tIns="0" bIns="0">
+            <a:spAutoFit/>
+          </a:bodyPr>
+          <a:lstStyle/>
+          <a:p>
+            <a:pPr algn="l">
+              <a:spcAft>
+                <a:spcPts val="600"/>
+              </a:spcAft>
+            </a:pPr>
+            <a:r>
+              <a:rPr sz="1300" b="0" i="1">
+                <a:solidFill>
+                  <a:srgbClr val="404040"/>
+                </a:solidFill>
+                <a:latin typeface="Arial"/>
+              </a:rPr>
+              <a:t>His 0.72 is a single value over all molecules. Ours can be ranked by confidence, so on the predictions it is most sure about it is far more accurate, which a single value cannot offer.</a:t>
+            </a:r>
+          </a:p>
+        </p:txBody>
+      </p:sp>
+    </p:spTree>
+  </p:cSld>
+  <p:clrMapOvr>
+    <a:masterClrMapping/>
+  </p:clrMapOvr>
+</p:sld>
+</file>
+
+<file path=ppt/slides/slide18.xml><?xml version="1.0" encoding="utf-8"?>
+<p:sld xmlns:a="http://schemas.openxmlformats.org/drawingml/2006/main" xmlns:p="http://schemas.openxmlformats.org/presentationml/2006/main" xmlns:r="http://schemas.openxmlformats.org/officeDocument/2006/relationships">
+  <p:cSld>
+    <p:bg>
+      <p:bgPr>
+        <a:solidFill>
+          <a:srgbClr val="FFFFFF"/>
+        </a:solidFill>
+        <a:effectLst/>
+      </p:bgPr>
+    </p:bg>
+    <p:spTree>
+      <p:nvGrpSpPr>
+        <p:cNvPr id="1" name=""/>
+        <p:cNvGrpSpPr/>
+        <p:nvPr/>
+      </p:nvGrpSpPr>
+      <p:grpSpPr/>
+      <p:sp>
+        <p:nvSpPr>
+          <p:cNvPr id="2" name="TextBox 1"/>
+          <p:cNvSpPr txBox="1"/>
+          <p:nvPr/>
+        </p:nvSpPr>
+        <p:spPr>
+          <a:xfrm>
+            <a:off x="640080" y="457200"/>
+            <a:ext cx="10972800" cy="914400"/>
+          </a:xfrm>
+          <a:prstGeom prst="rect">
+            <a:avLst/>
+          </a:prstGeom>
+          <a:noFill/>
+        </p:spPr>
+        <p:txBody>
+          <a:bodyPr wrap="square" lIns="0" rIns="0" tIns="0" bIns="0">
+            <a:spAutoFit/>
+          </a:bodyPr>
+          <a:lstStyle/>
+          <a:p>
+            <a:pPr algn="l">
+              <a:spcAft>
+                <a:spcPts val="600"/>
+              </a:spcAft>
+            </a:pPr>
+            <a:r>
+              <a:rPr sz="2900" b="1" i="0">
+                <a:solidFill>
+                  <a:srgbClr val="000000"/>
+                </a:solidFill>
+                <a:latin typeface="Arial"/>
+              </a:rPr>
               <a:t>Our model on Dr. Zhang's test set</a:t>
             </a:r>
           </a:p>
@@ -4249,7 +4378,7 @@
 </p:sld>
 </file>
 
-<file path=ppt/slides/slide18.xml><?xml version="1.0" encoding="utf-8"?>
+<file path=ppt/slides/slide19.xml><?xml version="1.0" encoding="utf-8"?>
 <p:sld xmlns:a="http://schemas.openxmlformats.org/drawingml/2006/main" xmlns:p="http://schemas.openxmlformats.org/presentationml/2006/main" xmlns:r="http://schemas.openxmlformats.org/officeDocument/2006/relationships">
   <p:cSld>
     <p:bg>
@@ -4584,134 +4713,6 @@
 </p:sld>
 </file>
 
-<file path=ppt/slides/slide19.xml><?xml version="1.0" encoding="utf-8"?>
-<p:sld xmlns:a="http://schemas.openxmlformats.org/drawingml/2006/main" xmlns:p="http://schemas.openxmlformats.org/presentationml/2006/main" xmlns:r="http://schemas.openxmlformats.org/officeDocument/2006/relationships">
-  <p:cSld>
-    <p:bg>
-      <p:bgPr>
-        <a:solidFill>
-          <a:srgbClr val="FFFFFF"/>
-        </a:solidFill>
-        <a:effectLst/>
-      </p:bgPr>
-    </p:bg>
-    <p:spTree>
-      <p:nvGrpSpPr>
-        <p:cNvPr id="1" name=""/>
-        <p:cNvGrpSpPr/>
-        <p:nvPr/>
-      </p:nvGrpSpPr>
-      <p:grpSpPr/>
-      <p:sp>
-        <p:nvSpPr>
-          <p:cNvPr id="2" name="TextBox 1"/>
-          <p:cNvSpPr txBox="1"/>
-          <p:nvPr/>
-        </p:nvSpPr>
-        <p:spPr>
-          <a:xfrm>
-            <a:off x="640080" y="457200"/>
-            <a:ext cx="10972800" cy="914400"/>
-          </a:xfrm>
-          <a:prstGeom prst="rect">
-            <a:avLst/>
-          </a:prstGeom>
-          <a:noFill/>
-        </p:spPr>
-        <p:txBody>
-          <a:bodyPr wrap="square" lIns="0" rIns="0" tIns="0" bIns="0">
-            <a:spAutoFit/>
-          </a:bodyPr>
-          <a:lstStyle/>
-          <a:p>
-            <a:pPr algn="l">
-              <a:spcAft>
-                <a:spcPts val="600"/>
-              </a:spcAft>
-            </a:pPr>
-            <a:r>
-              <a:rPr sz="2900" b="1" i="0">
-                <a:solidFill>
-                  <a:srgbClr val="000000"/>
-                </a:solidFill>
-                <a:latin typeface="Arial"/>
-              </a:rPr>
-              <a:t>Training on Dr. Zhang's data</a:t>
-            </a:r>
-          </a:p>
-        </p:txBody>
-      </p:sp>
-      <p:pic>
-        <p:nvPicPr>
-          <p:cNvPr id="3" name="Picture 2" descr="our_data_vs_zhang_data.png"/>
-          <p:cNvPicPr>
-            <a:picLocks noChangeAspect="1"/>
-          </p:cNvPicPr>
-          <p:nvPr/>
-        </p:nvPicPr>
-        <p:blipFill>
-          <a:blip r:embed="rId2"/>
-          <a:stretch>
-            <a:fillRect/>
-          </a:stretch>
-        </p:blipFill>
-        <p:spPr>
-          <a:xfrm>
-            <a:off x="2307482" y="1508760"/>
-            <a:ext cx="7576731" cy="3749039"/>
-          </a:xfrm>
-          <a:prstGeom prst="rect">
-            <a:avLst/>
-          </a:prstGeom>
-        </p:spPr>
-      </p:pic>
-      <p:sp>
-        <p:nvSpPr>
-          <p:cNvPr id="4" name="TextBox 3"/>
-          <p:cNvSpPr txBox="1"/>
-          <p:nvPr/>
-        </p:nvSpPr>
-        <p:spPr>
-          <a:xfrm>
-            <a:off x="640080" y="5404104"/>
-            <a:ext cx="10881360" cy="1005840"/>
-          </a:xfrm>
-          <a:prstGeom prst="rect">
-            <a:avLst/>
-          </a:prstGeom>
-          <a:noFill/>
-        </p:spPr>
-        <p:txBody>
-          <a:bodyPr wrap="square" lIns="0" rIns="0" tIns="0" bIns="0">
-            <a:spAutoFit/>
-          </a:bodyPr>
-          <a:lstStyle/>
-          <a:p>
-            <a:pPr algn="l">
-              <a:spcAft>
-                <a:spcPts val="600"/>
-              </a:spcAft>
-            </a:pPr>
-            <a:r>
-              <a:rPr sz="1300" b="0" i="1">
-                <a:solidFill>
-                  <a:srgbClr val="404040"/>
-                </a:solidFill>
-                <a:latin typeface="Arial"/>
-              </a:rPr>
-              <a:t>Training on his data reproduces our results, so his dataset is not better, it is the same; the edge is the feature engineering and the confidence layer, not the data.</a:t>
-            </a:r>
-          </a:p>
-        </p:txBody>
-      </p:sp>
-    </p:spTree>
-  </p:cSld>
-  <p:clrMapOvr>
-    <a:masterClrMapping/>
-  </p:clrMapOvr>
-</p:sld>
-</file>
-
 <file path=ppt/slides/slide2.xml><?xml version="1.0" encoding="utf-8"?>
 <p:sld xmlns:a="http://schemas.openxmlformats.org/drawingml/2006/main" xmlns:p="http://schemas.openxmlformats.org/presentationml/2006/main" xmlns:r="http://schemas.openxmlformats.org/officeDocument/2006/relationships">
   <p:cSld>
@@ -5088,6 +5089,134 @@
                 </a:solidFill>
                 <a:latin typeface="Arial"/>
               </a:rPr>
+              <a:t>Training on Dr. Zhang's data</a:t>
+            </a:r>
+          </a:p>
+        </p:txBody>
+      </p:sp>
+      <p:pic>
+        <p:nvPicPr>
+          <p:cNvPr id="3" name="Picture 2" descr="our_data_vs_zhang_data.png"/>
+          <p:cNvPicPr>
+            <a:picLocks noChangeAspect="1"/>
+          </p:cNvPicPr>
+          <p:nvPr/>
+        </p:nvPicPr>
+        <p:blipFill>
+          <a:blip r:embed="rId2"/>
+          <a:stretch>
+            <a:fillRect/>
+          </a:stretch>
+        </p:blipFill>
+        <p:spPr>
+          <a:xfrm>
+            <a:off x="2307482" y="1508760"/>
+            <a:ext cx="7576731" cy="3749039"/>
+          </a:xfrm>
+          <a:prstGeom prst="rect">
+            <a:avLst/>
+          </a:prstGeom>
+        </p:spPr>
+      </p:pic>
+      <p:sp>
+        <p:nvSpPr>
+          <p:cNvPr id="4" name="TextBox 3"/>
+          <p:cNvSpPr txBox="1"/>
+          <p:nvPr/>
+        </p:nvSpPr>
+        <p:spPr>
+          <a:xfrm>
+            <a:off x="640080" y="5404104"/>
+            <a:ext cx="10881360" cy="1005840"/>
+          </a:xfrm>
+          <a:prstGeom prst="rect">
+            <a:avLst/>
+          </a:prstGeom>
+          <a:noFill/>
+        </p:spPr>
+        <p:txBody>
+          <a:bodyPr wrap="square" lIns="0" rIns="0" tIns="0" bIns="0">
+            <a:spAutoFit/>
+          </a:bodyPr>
+          <a:lstStyle/>
+          <a:p>
+            <a:pPr algn="l">
+              <a:spcAft>
+                <a:spcPts val="600"/>
+              </a:spcAft>
+            </a:pPr>
+            <a:r>
+              <a:rPr sz="1300" b="0" i="1">
+                <a:solidFill>
+                  <a:srgbClr val="404040"/>
+                </a:solidFill>
+                <a:latin typeface="Arial"/>
+              </a:rPr>
+              <a:t>Training on his data reproduces our results, so his dataset is not better, it is the same; the edge is the feature engineering and the confidence layer, not the data.</a:t>
+            </a:r>
+          </a:p>
+        </p:txBody>
+      </p:sp>
+    </p:spTree>
+  </p:cSld>
+  <p:clrMapOvr>
+    <a:masterClrMapping/>
+  </p:clrMapOvr>
+</p:sld>
+</file>
+
+<file path=ppt/slides/slide21.xml><?xml version="1.0" encoding="utf-8"?>
+<p:sld xmlns:a="http://schemas.openxmlformats.org/drawingml/2006/main" xmlns:p="http://schemas.openxmlformats.org/presentationml/2006/main" xmlns:r="http://schemas.openxmlformats.org/officeDocument/2006/relationships">
+  <p:cSld>
+    <p:bg>
+      <p:bgPr>
+        <a:solidFill>
+          <a:srgbClr val="FFFFFF"/>
+        </a:solidFill>
+        <a:effectLst/>
+      </p:bgPr>
+    </p:bg>
+    <p:spTree>
+      <p:nvGrpSpPr>
+        <p:cNvPr id="1" name=""/>
+        <p:cNvGrpSpPr/>
+        <p:nvPr/>
+      </p:nvGrpSpPr>
+      <p:grpSpPr/>
+      <p:sp>
+        <p:nvSpPr>
+          <p:cNvPr id="2" name="TextBox 1"/>
+          <p:cNvSpPr txBox="1"/>
+          <p:nvPr/>
+        </p:nvSpPr>
+        <p:spPr>
+          <a:xfrm>
+            <a:off x="640080" y="457200"/>
+            <a:ext cx="10972800" cy="914400"/>
+          </a:xfrm>
+          <a:prstGeom prst="rect">
+            <a:avLst/>
+          </a:prstGeom>
+          <a:noFill/>
+        </p:spPr>
+        <p:txBody>
+          <a:bodyPr wrap="square" lIns="0" rIns="0" tIns="0" bIns="0">
+            <a:spAutoFit/>
+          </a:bodyPr>
+          <a:lstStyle/>
+          <a:p>
+            <a:pPr algn="l">
+              <a:spcAft>
+                <a:spcPts val="600"/>
+              </a:spcAft>
+            </a:pPr>
+            <a:r>
+              <a:rPr sz="2900" b="1" i="0">
+                <a:solidFill>
+                  <a:srgbClr val="000000"/>
+                </a:solidFill>
+                <a:latin typeface="Arial"/>
+              </a:rPr>
               <a:t>Summary</a:t>
             </a:r>
           </a:p>
@@ -5763,14 +5892,69 @@
                 </a:solidFill>
                 <a:latin typeface="Arial"/>
               </a:rPr>
-              <a:t>Accuracy versus confidence, Track A</a:t>
+              <a:t>What a 90 percent interval means</a:t>
+            </a:r>
+          </a:p>
+        </p:txBody>
+      </p:sp>
+      <p:sp>
+        <p:nvSpPr>
+          <p:cNvPr id="3" name="TextBox 2"/>
+          <p:cNvSpPr txBox="1"/>
+          <p:nvPr/>
+        </p:nvSpPr>
+        <p:spPr>
+          <a:xfrm>
+            <a:off x="640080" y="1280160"/>
+            <a:ext cx="10972800" cy="1783080"/>
+          </a:xfrm>
+          <a:prstGeom prst="rect">
+            <a:avLst/>
+          </a:prstGeom>
+          <a:noFill/>
+        </p:spPr>
+        <p:txBody>
+          <a:bodyPr wrap="square" lIns="0" rIns="0" tIns="0" bIns="0">
+            <a:spAutoFit/>
+          </a:bodyPr>
+          <a:lstStyle/>
+          <a:p>
+            <a:pPr algn="l">
+              <a:spcAft>
+                <a:spcPts val="800"/>
+              </a:spcAft>
+            </a:pPr>
+            <a:r>
+              <a:rPr sz="1500" b="0" i="0">
+                <a:solidFill>
+                  <a:srgbClr val="000000"/>
+                </a:solidFill>
+                <a:latin typeface="Arial"/>
+              </a:rPr>
+              <a:t>The model gives a range, not just a single number. For example, it might predict a logD of 1.5 and report that it is 90 percent sure the true value is between 0.6 and 2.4. Across many predictions, each with its own 90 percent range, the true value should land inside about 90 times out of 100, while an 80 percent range is narrower and contains it about 80 times out of 100.</a:t>
+            </a:r>
+          </a:p>
+          <a:p>
+            <a:pPr algn="l">
+              <a:spcAft>
+                <a:spcPts val="600"/>
+              </a:spcAft>
+            </a:pPr>
+            <a:r>
+              <a:rPr sz="1500" b="0" i="0">
+                <a:solidFill>
+                  <a:srgbClr val="000000"/>
+                </a:solidFill>
+                <a:latin typeface="Arial"/>
+              </a:rPr>
+              <a:t>Coverage is how often this actually happens. Checking every range against the real value, the true logD landed inside the 90 percent range 89 to 90 percent of the time, right on target, which is what it means to say the ranges are honest.</a:t>
             </a:r>
           </a:p>
         </p:txBody>
       </p:sp>
       <p:pic>
         <p:nvPicPr>
-          <p:cNvPr id="3" name="Picture 2" descr="confidence_curve_a.png"/>
+          <p:cNvPr id="4" name="Picture 3" descr="coverage_illustration.png"/>
           <p:cNvPicPr>
             <a:picLocks noChangeAspect="1"/>
           </p:cNvPicPr>
@@ -5784,53 +5968,14 @@
         </p:blipFill>
         <p:spPr>
           <a:xfrm>
-            <a:off x="792327" y="1508760"/>
-            <a:ext cx="10607040" cy="3787693"/>
+            <a:off x="3219269" y="3154680"/>
+            <a:ext cx="5753155" cy="3429000"/>
           </a:xfrm>
           <a:prstGeom prst="rect">
             <a:avLst/>
           </a:prstGeom>
         </p:spPr>
       </p:pic>
-      <p:sp>
-        <p:nvSpPr>
-          <p:cNvPr id="4" name="TextBox 3"/>
-          <p:cNvSpPr txBox="1"/>
-          <p:nvPr/>
-        </p:nvSpPr>
-        <p:spPr>
-          <a:xfrm>
-            <a:off x="640080" y="5442757"/>
-            <a:ext cx="10881360" cy="1005840"/>
-          </a:xfrm>
-          <a:prstGeom prst="rect">
-            <a:avLst/>
-          </a:prstGeom>
-          <a:noFill/>
-        </p:spPr>
-        <p:txBody>
-          <a:bodyPr wrap="square" lIns="0" rIns="0" tIns="0" bIns="0">
-            <a:spAutoFit/>
-          </a:bodyPr>
-          <a:lstStyle/>
-          <a:p>
-            <a:pPr algn="l">
-              <a:spcAft>
-                <a:spcPts val="600"/>
-              </a:spcAft>
-            </a:pPr>
-            <a:r>
-              <a:rPr sz="1300" b="0" i="1">
-                <a:solidFill>
-                  <a:srgbClr val="404040"/>
-                </a:solidFill>
-                <a:latin typeface="Arial"/>
-              </a:rPr>
-              <a:t>Moving right to left keeps fewer but more confident predictions. The most confident tenth (the tenth with the smallest estimated error) reaches R-squared 0.912 and RMSE 0.493, against 0.466 and 1.148 over all predictions.</a:t>
-            </a:r>
-          </a:p>
-        </p:txBody>
-      </p:sp>
     </p:spTree>
   </p:cSld>
   <p:clrMapOvr>
@@ -5891,14 +6036,14 @@
                 </a:solidFill>
                 <a:latin typeface="Arial"/>
               </a:rPr>
-              <a:t>Accuracy versus confidence, Track B</a:t>
+              <a:t>Accuracy versus confidence, Track A</a:t>
             </a:r>
           </a:p>
         </p:txBody>
       </p:sp>
       <p:pic>
         <p:nvPicPr>
-          <p:cNvPr id="3" name="Picture 2" descr="confidence_curve_b.png"/>
+          <p:cNvPr id="3" name="Picture 2" descr="confidence_curve_a.png"/>
           <p:cNvPicPr>
             <a:picLocks noChangeAspect="1"/>
           </p:cNvPicPr>
@@ -5954,7 +6099,7 @@
                 </a:solidFill>
                 <a:latin typeface="Arial"/>
               </a:rPr>
-              <a:t>The same pattern holds for condition optimization: the most confident tenth reaches R-squared 0.940 and RMSE 0.341, against 0.725 and 0.823 over all predictions.</a:t>
+              <a:t>Moving right to left keeps fewer but more confident predictions. The most confident tenth (the tenth with the smallest estimated error) reaches R-squared 0.912 and RMSE 0.493, against 0.466 and 1.148 over all predictions.</a:t>
             </a:r>
           </a:p>
         </p:txBody>
@@ -6019,14 +6164,14 @@
                 </a:solidFill>
                 <a:latin typeface="Arial"/>
               </a:rPr>
-              <a:t>Predicted versus actual logD</a:t>
+              <a:t>Accuracy versus confidence, Track B</a:t>
             </a:r>
           </a:p>
         </p:txBody>
       </p:sp>
       <p:pic>
         <p:nvPicPr>
-          <p:cNvPr id="3" name="Picture 2" descr="pred_vs_actual_a.png"/>
+          <p:cNvPr id="3" name="Picture 2" descr="confidence_curve_b.png"/>
           <p:cNvPicPr>
             <a:picLocks noChangeAspect="1"/>
           </p:cNvPicPr>
@@ -6040,47 +6185,23 @@
         </p:blipFill>
         <p:spPr>
           <a:xfrm>
-            <a:off x="1097280" y="1600200"/>
-            <a:ext cx="4722725" cy="4297680"/>
+            <a:off x="792327" y="1508760"/>
+            <a:ext cx="10607040" cy="3787693"/>
           </a:xfrm>
           <a:prstGeom prst="rect">
             <a:avLst/>
           </a:prstGeom>
         </p:spPr>
       </p:pic>
-      <p:pic>
-        <p:nvPicPr>
-          <p:cNvPr id="4" name="Picture 3" descr="pred_vs_actual_b.png"/>
-          <p:cNvPicPr>
-            <a:picLocks noChangeAspect="1"/>
-          </p:cNvPicPr>
-          <p:nvPr/>
-        </p:nvPicPr>
-        <p:blipFill>
-          <a:blip r:embed="rId3"/>
-          <a:stretch>
-            <a:fillRect/>
-          </a:stretch>
-        </p:blipFill>
-        <p:spPr>
-          <a:xfrm>
-            <a:off x="6309360" y="1600200"/>
-            <a:ext cx="4796939" cy="4297680"/>
-          </a:xfrm>
-          <a:prstGeom prst="rect">
-            <a:avLst/>
-          </a:prstGeom>
-        </p:spPr>
-      </p:pic>
-      <p:sp>
-        <p:nvSpPr>
-          <p:cNvPr id="5" name="TextBox 4"/>
+      <p:sp>
+        <p:nvSpPr>
+          <p:cNvPr id="4" name="TextBox 3"/>
           <p:cNvSpPr txBox="1"/>
           <p:nvPr/>
         </p:nvSpPr>
         <p:spPr>
           <a:xfrm>
-            <a:off x="640080" y="6080760"/>
+            <a:off x="640080" y="5442757"/>
             <a:ext cx="10881360" cy="1005840"/>
           </a:xfrm>
           <a:prstGeom prst="rect">
@@ -6106,7 +6227,7 @@
                 </a:solidFill>
                 <a:latin typeface="Arial"/>
               </a:rPr>
-              <a:t>Left: Track A, new molecules. Right: Track B, known molecules. Each point is a prediction; darker points are the more confident ones and lie closer to the diagonal, where predicted equals actual.</a:t>
+              <a:t>The same pattern holds for condition optimization: the most confident tenth reaches R-squared 0.940 and RMSE 0.341, against 0.725 and 0.823 over all predictions.</a:t>
             </a:r>
           </a:p>
         </p:txBody>
@@ -6171,14 +6292,14 @@
                 </a:solidFill>
                 <a:latin typeface="Arial"/>
               </a:rPr>
-              <a:t>Accuracy by metal</a:t>
+              <a:t>Predicted versus actual logD</a:t>
             </a:r>
           </a:p>
         </p:txBody>
       </p:sp>
       <p:pic>
         <p:nvPicPr>
-          <p:cNvPr id="3" name="Picture 2" descr="by_metal_accuracy.png"/>
+          <p:cNvPr id="3" name="Picture 2" descr="pred_vs_actual_a.png"/>
           <p:cNvPicPr>
             <a:picLocks noChangeAspect="1"/>
           </p:cNvPicPr>
@@ -6192,23 +6313,47 @@
         </p:blipFill>
         <p:spPr>
           <a:xfrm>
-            <a:off x="1270309" y="1508760"/>
-            <a:ext cx="9651076" cy="4114800"/>
+            <a:off x="1097280" y="1600200"/>
+            <a:ext cx="4722725" cy="4297680"/>
           </a:xfrm>
           <a:prstGeom prst="rect">
             <a:avLst/>
           </a:prstGeom>
         </p:spPr>
       </p:pic>
-      <p:sp>
-        <p:nvSpPr>
-          <p:cNvPr id="4" name="TextBox 3"/>
+      <p:pic>
+        <p:nvPicPr>
+          <p:cNvPr id="4" name="Picture 3" descr="pred_vs_actual_b.png"/>
+          <p:cNvPicPr>
+            <a:picLocks noChangeAspect="1"/>
+          </p:cNvPicPr>
+          <p:nvPr/>
+        </p:nvPicPr>
+        <p:blipFill>
+          <a:blip r:embed="rId3"/>
+          <a:stretch>
+            <a:fillRect/>
+          </a:stretch>
+        </p:blipFill>
+        <p:spPr>
+          <a:xfrm>
+            <a:off x="6309360" y="1600200"/>
+            <a:ext cx="4796939" cy="4297680"/>
+          </a:xfrm>
+          <a:prstGeom prst="rect">
+            <a:avLst/>
+          </a:prstGeom>
+        </p:spPr>
+      </p:pic>
+      <p:sp>
+        <p:nvSpPr>
+          <p:cNvPr id="5" name="TextBox 4"/>
           <p:cNvSpPr txBox="1"/>
           <p:nvPr/>
         </p:nvSpPr>
         <p:spPr>
           <a:xfrm>
-            <a:off x="640080" y="5769864"/>
+            <a:off x="640080" y="6080760"/>
             <a:ext cx="10881360" cy="1005840"/>
           </a:xfrm>
           <a:prstGeom prst="rect">
@@ -6234,7 +6379,7 @@
                 </a:solidFill>
                 <a:latin typeface="Arial"/>
               </a:rPr>
-              <a:t>Accuracy is not uniform. It is highest on Americium and Curium and lowest on Neptunium(V), Erbium, and Uranium(VI), so a single overall number hides large differences between metals.</a:t>
+              <a:t>Left: Track A, new molecules. Right: Track B, known molecules. Each point is a prediction; darker points are the more confident ones and lie closer to the diagonal, where predicted equals actual.</a:t>
             </a:r>
           </a:p>
         </p:txBody>
@@ -6299,14 +6444,14 @@
                 </a:solidFill>
                 <a:latin typeface="Arial"/>
               </a:rPr>
-              <a:t>Confidence by metal</a:t>
+              <a:t>Accuracy by metal</a:t>
             </a:r>
           </a:p>
         </p:txBody>
       </p:sp>
       <p:pic>
         <p:nvPicPr>
-          <p:cNvPr id="3" name="Picture 2" descr="confidence_per_metal.png"/>
+          <p:cNvPr id="3" name="Picture 2" descr="by_metal_accuracy.png"/>
           <p:cNvPicPr>
             <a:picLocks noChangeAspect="1"/>
           </p:cNvPicPr>
@@ -6320,8 +6465,8 @@
         </p:blipFill>
         <p:spPr>
           <a:xfrm>
-            <a:off x="2308061" y="1508760"/>
-            <a:ext cx="7575571" cy="4297680"/>
+            <a:off x="1270309" y="1508760"/>
+            <a:ext cx="9651076" cy="4114800"/>
           </a:xfrm>
           <a:prstGeom prst="rect">
             <a:avLst/>
@@ -6336,7 +6481,7 @@
         </p:nvSpPr>
         <p:spPr>
           <a:xfrm>
-            <a:off x="640080" y="5952744"/>
+            <a:off x="640080" y="5769864"/>
             <a:ext cx="10881360" cy="1005840"/>
           </a:xfrm>
           <a:prstGeom prst="rect">
@@ -6362,7 +6507,7 @@
                 </a:solidFill>
                 <a:latin typeface="Arial"/>
               </a:rPr>
-              <a:t>Each bar is the model's median estimated error for a metal, which is its confidence signal, so a shorter bar means it is more sure. The model is most confident on Americium and Curium and least confident on Neptunium(V), Uranium(VI), and Erbium.</a:t>
+              <a:t>Accuracy is not uniform. It is highest on Americium and Curium and lowest on Neptunium(V), Erbium, and Uranium(VI), so a single overall number hides large differences between metals.</a:t>
             </a:r>
           </a:p>
         </p:txBody>

</xml_diff>